<commit_message>
Day 1: the folder as it now stands
  - 10:05 gains its two PDF exports, and both decks were re-saved
  - the three RAG source PDFs are renamed, so their buttons read
    "PDF · EN · Continental AI Strategy July 2024" rather than carrying the
    scanner's reference number. git records them as pure renames; the third now
    carries _EN, so its language is read instead of being left off
  - both RAG notebooks come back clean: 0 cells with outputs, against 24 this
    morning, so the check that blocked this morning's deploy has nothing left
    to report on them
  - 1400_ai-infrastructure_FR.pptx re-saved. PowerPoint holds both 14:00 decks
    open, so the file was checked before committing: size stable, archive valid,
    slides readable.

Pages regenerated with tools/build_site.py alone; the two agenda PDFs are
untouched.
</commit_message>
<xml_diff>
--- a/docs/downloads/Day1/1005_ai-family-tree_EN.pptx
+++ b/docs/downloads/Day1/1005_ai-family-tree_EN.pptx
@@ -5,7 +5,7 @@
     <p:sldMasterId id="2147483648" r:id="rId1"/>
   </p:sldMasterIdLst>
   <p:notesMasterIdLst>
-    <p:notesMasterId r:id="rId41"/>
+    <p:notesMasterId r:id="rId39"/>
   </p:notesMasterIdLst>
   <p:sldIdLst>
     <p:sldId id="256" r:id="rId2"/>
@@ -38,15 +38,13 @@
     <p:sldId id="283" r:id="rId29"/>
     <p:sldId id="284" r:id="rId30"/>
     <p:sldId id="285" r:id="rId31"/>
-    <p:sldId id="286" r:id="rId32"/>
-    <p:sldId id="287" r:id="rId33"/>
-    <p:sldId id="288" r:id="rId34"/>
-    <p:sldId id="289" r:id="rId35"/>
-    <p:sldId id="290" r:id="rId36"/>
-    <p:sldId id="291" r:id="rId37"/>
-    <p:sldId id="292" r:id="rId38"/>
-    <p:sldId id="293" r:id="rId39"/>
-    <p:sldId id="294" r:id="rId40"/>
+    <p:sldId id="287" r:id="rId32"/>
+    <p:sldId id="288" r:id="rId33"/>
+    <p:sldId id="289" r:id="rId34"/>
+    <p:sldId id="290" r:id="rId35"/>
+    <p:sldId id="292" r:id="rId36"/>
+    <p:sldId id="293" r:id="rId37"/>
+    <p:sldId id="294" r:id="rId38"/>
   </p:sldIdLst>
   <p:sldSz cx="9144000" cy="5143500" type="screen16x9"/>
   <p:notesSz cx="5143500" cy="9144000"/>
@@ -2985,7 +2983,7 @@
           <a:p>
             <a:r>
               <a:rPr lang="en-US" dirty="0"/>
-              <a:t>Don't thank, don't summarise. End on the instruction: bring a real question from their office to the lab. Labs go badly when participants arrive with a textbook question, and well when they arrive with a question their director actually asked them. At 15:00 they will add the third column and give it tools.</a:t>
+              <a:t>Backup slides, to be used only if questions call for them.</a:t>
             </a:r>
           </a:p>
         </p:txBody>
@@ -3072,7 +3070,7 @@
           <a:p>
             <a:r>
               <a:rPr lang="en-US" dirty="0"/>
-              <a:t>Backup slides, to be used only if questions call for them.</a:t>
+              <a:t>Reference glossary for a bilingual audience. Point out that LLM corresponds to GML (grand modèle de langage) in French, and that French-speaking colleagues will see the French terms in the French version of this deck.</a:t>
             </a:r>
           </a:p>
         </p:txBody>
@@ -3159,7 +3157,7 @@
           <a:p>
             <a:r>
               <a:rPr lang="en-US" dirty="0"/>
-              <a:t>Reference glossary for a bilingual audience. Point out that LLM corresponds to GML (grand modèle de langage) in French, and that French-speaking colleagues will see the French terms in the French version of this deck.</a:t>
+              <a:t>Use if someone asks how machine learning relates to their profession. Breiman was one of them and was addressing statisticians. Machine learning did not replace statistics; it made a different trade-off, giving up interpretability to buy predictive accuracy.</a:t>
             </a:r>
           </a:p>
         </p:txBody>
@@ -3246,7 +3244,7 @@
           <a:p>
             <a:r>
               <a:rPr lang="en-US" dirty="0"/>
-              <a:t>Use if someone asks how machine learning relates to their profession. Breiman was one of them and was addressing statisticians. Machine learning did not replace statistics; it made a different trade-off, giving up interpretability to buy predictive accuracy.</a:t>
+              <a:t>Use if the taxonomy question comes up. Anchor each family in what participants already hold. Say frankly that reinforcement learning has very few direct uses in official statistics, even though it is used to train LLMs to follow instructions.</a:t>
             </a:r>
           </a:p>
         </p:txBody>
@@ -3333,7 +3331,7 @@
           <a:p>
             <a:r>
               <a:rPr lang="en-US" dirty="0"/>
-              <a:t>Use if the taxonomy question comes up. Anchor each family in what participants already hold. Say frankly that reinforcement learning has very few direct uses in official statistics, even though it is used to train LLMs to follow instructions.</a:t>
+              <a:t>Full sources. References added in this version cover the notion of a model (Box), AI-ready data (Commerce, FCSM, IMF), AGI (Legg &amp; Hutter, Chollet, Morris et al., Grace et al., Blili-Hamelin et al.) and the current governance of MCP. Check the MCP specification version on the day.</a:t>
             </a:r>
           </a:p>
         </p:txBody>
@@ -3420,7 +3418,7 @@
           <a:p>
             <a:r>
               <a:rPr lang="en-US" dirty="0"/>
-              <a:t>Use if someone asks whether they should train their own model. The answer removes a decision rather than adding one. Distinguish pre-training from fine-tuning explicitly: they are constantly confused, and only the first is out of reach.</a:t>
+              <a:t>Full sources. References added in this version cover the notion of a model (Box), AI-ready data (Commerce, FCSM, IMF), AGI (Legg &amp; Hutter, Chollet, Morris et al., Grace et al., Blili-Hamelin et al.) and the current governance of MCP. Check the MCP specification version on the day.</a:t>
             </a:r>
           </a:p>
         </p:txBody>
@@ -3530,180 +3528,6 @@
             <a:fld id="{F7021451-1387-4CA6-816F-3879F97B5CBC}" type="slidenum">
               <a:rPr lang="en-US"/>
               <a:t>37</a:t>
-            </a:fld>
-            <a:endParaRPr lang="en-US"/>
-          </a:p>
-        </p:txBody>
-      </p:sp>
-    </p:spTree>
-    <p:extLst>
-      <p:ext uri="{BB962C8B-B14F-4D97-AF65-F5344CB8AC3E}">
-        <p14:creationId xmlns:p14="http://schemas.microsoft.com/office/powerpoint/2010/main" val="1024086991"/>
-      </p:ext>
-    </p:extLst>
-  </p:cSld>
-  <p:clrMapOvr>
-    <a:masterClrMapping/>
-  </p:clrMapOvr>
-</p:notes>
-</file>
-
-<file path=ppt/notesSlides/notesSlide38.xml><?xml version="1.0" encoding="utf-8"?>
-<p:notes xmlns:a="http://schemas.openxmlformats.org/drawingml/2006/main" xmlns:r="http://schemas.openxmlformats.org/officeDocument/2006/relationships" xmlns:p="http://schemas.openxmlformats.org/presentationml/2006/main">
-  <p:cSld>
-    <p:spTree>
-      <p:nvGrpSpPr>
-        <p:cNvPr id="1" name=""/>
-        <p:cNvGrpSpPr/>
-        <p:nvPr/>
-      </p:nvGrpSpPr>
-      <p:grpSpPr>
-        <a:xfrm>
-          <a:off x="0" y="0"/>
-          <a:ext cx="0" cy="0"/>
-          <a:chOff x="0" y="0"/>
-          <a:chExt cx="0" cy="0"/>
-        </a:xfrm>
-      </p:grpSpPr>
-      <p:sp>
-        <p:nvSpPr>
-          <p:cNvPr id="2" name="Slide Image Placeholder 1"/>
-          <p:cNvSpPr>
-            <a:spLocks noGrp="1" noRot="1" noChangeAspect="1"/>
-          </p:cNvSpPr>
-          <p:nvPr>
-            <p:ph type="sldImg"/>
-          </p:nvPr>
-        </p:nvSpPr>
-        <p:spPr/>
-      </p:sp>
-      <p:sp>
-        <p:nvSpPr>
-          <p:cNvPr id="3" name="Notes Placeholder 2"/>
-          <p:cNvSpPr>
-            <a:spLocks noGrp="1"/>
-          </p:cNvSpPr>
-          <p:nvPr>
-            <p:ph type="body" idx="1"/>
-          </p:nvPr>
-        </p:nvSpPr>
-        <p:spPr/>
-        <p:txBody>
-          <a:bodyPr/>
-          <a:lstStyle/>
-          <a:p>
-            <a:r>
-              <a:rPr lang="en-US" dirty="0"/>
-              <a:t>Full sources. References added in this version cover the notion of a model (Box), AI-ready data (Commerce, FCSM, IMF), AGI (Legg &amp; Hutter, Chollet, Morris et al., Grace et al., Blili-Hamelin et al.) and the current governance of MCP. Check the MCP specification version on the day.</a:t>
-            </a:r>
-          </a:p>
-        </p:txBody>
-      </p:sp>
-      <p:sp>
-        <p:nvSpPr>
-          <p:cNvPr id="4" name="Slide Number Placeholder 3"/>
-          <p:cNvSpPr>
-            <a:spLocks noGrp="1"/>
-          </p:cNvSpPr>
-          <p:nvPr>
-            <p:ph type="sldNum" sz="quarter" idx="10"/>
-          </p:nvPr>
-        </p:nvSpPr>
-        <p:spPr/>
-        <p:txBody>
-          <a:bodyPr/>
-          <a:lstStyle/>
-          <a:p>
-            <a:fld id="{F7021451-1387-4CA6-816F-3879F97B5CBC}" type="slidenum">
-              <a:rPr lang="en-US"/>
-              <a:t>38</a:t>
-            </a:fld>
-            <a:endParaRPr lang="en-US"/>
-          </a:p>
-        </p:txBody>
-      </p:sp>
-    </p:spTree>
-    <p:extLst>
-      <p:ext uri="{BB962C8B-B14F-4D97-AF65-F5344CB8AC3E}">
-        <p14:creationId xmlns:p14="http://schemas.microsoft.com/office/powerpoint/2010/main" val="1024086991"/>
-      </p:ext>
-    </p:extLst>
-  </p:cSld>
-  <p:clrMapOvr>
-    <a:masterClrMapping/>
-  </p:clrMapOvr>
-</p:notes>
-</file>
-
-<file path=ppt/notesSlides/notesSlide39.xml><?xml version="1.0" encoding="utf-8"?>
-<p:notes xmlns:a="http://schemas.openxmlformats.org/drawingml/2006/main" xmlns:r="http://schemas.openxmlformats.org/officeDocument/2006/relationships" xmlns:p="http://schemas.openxmlformats.org/presentationml/2006/main">
-  <p:cSld>
-    <p:spTree>
-      <p:nvGrpSpPr>
-        <p:cNvPr id="1" name=""/>
-        <p:cNvGrpSpPr/>
-        <p:nvPr/>
-      </p:nvGrpSpPr>
-      <p:grpSpPr>
-        <a:xfrm>
-          <a:off x="0" y="0"/>
-          <a:ext cx="0" cy="0"/>
-          <a:chOff x="0" y="0"/>
-          <a:chExt cx="0" cy="0"/>
-        </a:xfrm>
-      </p:grpSpPr>
-      <p:sp>
-        <p:nvSpPr>
-          <p:cNvPr id="2" name="Slide Image Placeholder 1"/>
-          <p:cNvSpPr>
-            <a:spLocks noGrp="1" noRot="1" noChangeAspect="1"/>
-          </p:cNvSpPr>
-          <p:nvPr>
-            <p:ph type="sldImg"/>
-          </p:nvPr>
-        </p:nvSpPr>
-        <p:spPr/>
-      </p:sp>
-      <p:sp>
-        <p:nvSpPr>
-          <p:cNvPr id="3" name="Notes Placeholder 2"/>
-          <p:cNvSpPr>
-            <a:spLocks noGrp="1"/>
-          </p:cNvSpPr>
-          <p:nvPr>
-            <p:ph type="body" idx="1"/>
-          </p:nvPr>
-        </p:nvSpPr>
-        <p:spPr/>
-        <p:txBody>
-          <a:bodyPr/>
-          <a:lstStyle/>
-          <a:p>
-            <a:r>
-              <a:rPr lang="en-US" dirty="0"/>
-              <a:t>Full sources. References added in this version cover the notion of a model (Box), AI-ready data (Commerce, FCSM, IMF), AGI (Legg &amp; Hutter, Chollet, Morris et al., Grace et al., Blili-Hamelin et al.) and the current governance of MCP. Check the MCP specification version on the day.</a:t>
-            </a:r>
-          </a:p>
-        </p:txBody>
-      </p:sp>
-      <p:sp>
-        <p:nvSpPr>
-          <p:cNvPr id="4" name="Slide Number Placeholder 3"/>
-          <p:cNvSpPr>
-            <a:spLocks noGrp="1"/>
-          </p:cNvSpPr>
-          <p:nvPr>
-            <p:ph type="sldNum" sz="quarter" idx="10"/>
-          </p:nvPr>
-        </p:nvSpPr>
-        <p:spPr/>
-        <p:txBody>
-          <a:bodyPr/>
-          <a:lstStyle/>
-          <a:p>
-            <a:fld id="{F7021451-1387-4CA6-816F-3879F97B5CBC}" type="slidenum">
-              <a:rPr lang="en-US"/>
-              <a:t>39</a:t>
             </a:fld>
             <a:endParaRPr lang="en-US"/>
           </a:p>
@@ -34643,678 +34467,6 @@
 
 <file path=ppt/slides/slide31.xml><?xml version="1.0" encoding="utf-8"?>
 <p:sld xmlns:a="http://schemas.openxmlformats.org/drawingml/2006/main" xmlns:r="http://schemas.openxmlformats.org/officeDocument/2006/relationships" xmlns:p="http://schemas.openxmlformats.org/presentationml/2006/main">
-  <p:cSld name="Slide 31">
-    <p:bg>
-      <p:bgPr>
-        <a:blipFill dpi="0" rotWithShape="1">
-          <a:blip r:embed="rId3">
-            <a:lum/>
-          </a:blip>
-          <a:srcRect/>
-          <a:stretch>
-            <a:fillRect/>
-          </a:stretch>
-        </a:blipFill>
-        <a:effectLst/>
-      </p:bgPr>
-    </p:bg>
-    <p:spTree>
-      <p:nvGrpSpPr>
-        <p:cNvPr id="1" name=""/>
-        <p:cNvGrpSpPr/>
-        <p:nvPr/>
-      </p:nvGrpSpPr>
-      <p:grpSpPr>
-        <a:xfrm>
-          <a:off x="0" y="0"/>
-          <a:ext cx="0" cy="0"/>
-          <a:chOff x="0" y="0"/>
-          <a:chExt cx="0" cy="0"/>
-        </a:xfrm>
-      </p:grpSpPr>
-      <p:sp>
-        <p:nvSpPr>
-          <p:cNvPr id="2" name="Text 0"/>
-          <p:cNvSpPr txBox="1"/>
-          <p:nvPr/>
-        </p:nvSpPr>
-        <p:spPr>
-          <a:xfrm>
-            <a:off x="548640" y="685800"/>
-            <a:ext cx="4572000" cy="228600"/>
-          </a:xfrm>
-          <a:prstGeom prst="rect">
-            <a:avLst/>
-          </a:prstGeom>
-          <a:noFill/>
-          <a:ln/>
-        </p:spPr>
-        <p:txBody>
-          <a:bodyPr wrap="square" lIns="0" tIns="0" rIns="0" bIns="0" rtlCol="0" anchor="t"/>
-          <a:lstStyle/>
-          <a:p>
-            <a:pPr marL="0" indent="0">
-              <a:buNone/>
-            </a:pPr>
-            <a:r>
-              <a:rPr lang="en-US" sz="1050" b="1" kern="0" spc="300" dirty="0">
-                <a:solidFill>
-                  <a:srgbClr val="F5C242"/>
-                </a:solidFill>
-                <a:latin typeface="Calibri" pitchFamily="34" charset="0"/>
-                <a:ea typeface="Calibri" pitchFamily="34" charset="-122"/>
-                <a:cs typeface="Calibri" pitchFamily="34" charset="-120"/>
-              </a:rPr>
-              <a:t>WHAT'S NEXT ON DAY 1</a:t>
-            </a:r>
-            <a:endParaRPr lang="en-US" sz="1050" dirty="0"/>
-          </a:p>
-        </p:txBody>
-      </p:sp>
-      <p:sp>
-        <p:nvSpPr>
-          <p:cNvPr id="3" name="Text 1"/>
-          <p:cNvSpPr txBox="1"/>
-          <p:nvPr/>
-        </p:nvSpPr>
-        <p:spPr>
-          <a:xfrm>
-            <a:off x="548640" y="960120"/>
-            <a:ext cx="8138160" cy="777240"/>
-          </a:xfrm>
-          <a:prstGeom prst="rect">
-            <a:avLst/>
-          </a:prstGeom>
-          <a:noFill/>
-          <a:ln/>
-        </p:spPr>
-        <p:txBody>
-          <a:bodyPr wrap="square" lIns="0" tIns="0" rIns="0" bIns="0" rtlCol="0" anchor="ctr"/>
-          <a:lstStyle/>
-          <a:p>
-            <a:pPr marL="0" indent="0">
-              <a:buNone/>
-            </a:pPr>
-            <a:r>
-              <a:rPr lang="en-US" sz="3200" b="1" dirty="0">
-                <a:solidFill>
-                  <a:srgbClr val="FFFFFF"/>
-                </a:solidFill>
-                <a:latin typeface="Calibri" pitchFamily="34" charset="0"/>
-                <a:ea typeface="Calibri" pitchFamily="34" charset="-122"/>
-                <a:cs typeface="Calibri" pitchFamily="34" charset="-120"/>
-              </a:rPr>
-              <a:t>At 10:30, you will build the middle column.</a:t>
-            </a:r>
-            <a:endParaRPr lang="en-US" sz="3200" dirty="0"/>
-          </a:p>
-        </p:txBody>
-      </p:sp>
-      <p:sp>
-        <p:nvSpPr>
-          <p:cNvPr id="4" name="Text 2"/>
-          <p:cNvSpPr txBox="1"/>
-          <p:nvPr/>
-        </p:nvSpPr>
-        <p:spPr>
-          <a:xfrm>
-            <a:off x="548640" y="1783080"/>
-            <a:ext cx="6858000" cy="457200"/>
-          </a:xfrm>
-          <a:prstGeom prst="rect">
-            <a:avLst/>
-          </a:prstGeom>
-          <a:noFill/>
-          <a:ln/>
-        </p:spPr>
-        <p:txBody>
-          <a:bodyPr wrap="square" lIns="0" tIns="0" rIns="0" bIns="0" rtlCol="0" anchor="t"/>
-          <a:lstStyle/>
-          <a:p>
-            <a:pPr marL="0" indent="0">
-              <a:buNone/>
-            </a:pPr>
-            <a:r>
-              <a:rPr lang="en-US" sz="1600" i="1" dirty="0">
-                <a:solidFill>
-                  <a:srgbClr val="E6F6EE"/>
-                </a:solidFill>
-                <a:latin typeface="Calibri" pitchFamily="34" charset="0"/>
-                <a:ea typeface="Calibri" pitchFamily="34" charset="-122"/>
-                <a:cs typeface="Calibri" pitchFamily="34" charset="-120"/>
-              </a:rPr>
-              <a:t>RAG is the only setup in this stack that forces a model to show where its answer came from.</a:t>
-            </a:r>
-            <a:endParaRPr lang="en-US" sz="1600" dirty="0"/>
-          </a:p>
-        </p:txBody>
-      </p:sp>
-      <p:sp>
-        <p:nvSpPr>
-          <p:cNvPr id="5" name="Shape 3"/>
-          <p:cNvSpPr/>
-          <p:nvPr/>
-        </p:nvSpPr>
-        <p:spPr>
-          <a:xfrm>
-            <a:off x="548640" y="2514600"/>
-            <a:ext cx="2514600" cy="1143000"/>
-          </a:xfrm>
-          <a:prstGeom prst="roundRect">
-            <a:avLst>
-              <a:gd name="adj" fmla="val 6400"/>
-            </a:avLst>
-          </a:prstGeom>
-          <a:solidFill>
-            <a:srgbClr val="FFFFFF">
-              <a:alpha val="12000"/>
-            </a:srgbClr>
-          </a:solidFill>
-          <a:ln w="9525">
-            <a:solidFill>
-              <a:srgbClr val="FFFFFF">
-                <a:alpha val="50000"/>
-              </a:srgbClr>
-            </a:solidFill>
-            <a:prstDash val="solid"/>
-          </a:ln>
-        </p:spPr>
-      </p:sp>
-      <p:pic>
-        <p:nvPicPr>
-          <p:cNvPr id="6" name="Image 0" descr="preencoded.png"/>
-          <p:cNvPicPr>
-            <a:picLocks noChangeAspect="1"/>
-          </p:cNvPicPr>
-          <p:nvPr/>
-        </p:nvPicPr>
-        <p:blipFill>
-          <a:blip r:embed="rId4"/>
-          <a:stretch>
-            <a:fillRect/>
-          </a:stretch>
-        </p:blipFill>
-        <p:spPr>
-          <a:xfrm>
-            <a:off x="713232" y="2670048"/>
-            <a:ext cx="310896" cy="310896"/>
-          </a:xfrm>
-          <a:prstGeom prst="rect">
-            <a:avLst/>
-          </a:prstGeom>
-        </p:spPr>
-      </p:pic>
-      <p:sp>
-        <p:nvSpPr>
-          <p:cNvPr id="7" name="Text 4"/>
-          <p:cNvSpPr txBox="1"/>
-          <p:nvPr/>
-        </p:nvSpPr>
-        <p:spPr>
-          <a:xfrm>
-            <a:off x="1115568" y="2651760"/>
-            <a:ext cx="1737360" cy="347472"/>
-          </a:xfrm>
-          <a:prstGeom prst="rect">
-            <a:avLst/>
-          </a:prstGeom>
-          <a:noFill/>
-          <a:ln/>
-        </p:spPr>
-        <p:txBody>
-          <a:bodyPr wrap="square" lIns="0" tIns="0" rIns="0" bIns="0" rtlCol="0" anchor="ctr"/>
-          <a:lstStyle/>
-          <a:p>
-            <a:pPr marL="0" indent="0">
-              <a:buNone/>
-            </a:pPr>
-            <a:r>
-              <a:rPr lang="en-US" sz="2000" b="1" dirty="0">
-                <a:solidFill>
-                  <a:srgbClr val="F5C242"/>
-                </a:solidFill>
-                <a:latin typeface="Calibri" pitchFamily="34" charset="0"/>
-                <a:ea typeface="Calibri" pitchFamily="34" charset="-122"/>
-                <a:cs typeface="Calibri" pitchFamily="34" charset="-120"/>
-              </a:rPr>
-              <a:t>10:30</a:t>
-            </a:r>
-            <a:endParaRPr lang="en-US" sz="2000" dirty="0"/>
-          </a:p>
-        </p:txBody>
-      </p:sp>
-      <p:sp>
-        <p:nvSpPr>
-          <p:cNvPr id="8" name="Text 5"/>
-          <p:cNvSpPr txBox="1"/>
-          <p:nvPr/>
-        </p:nvSpPr>
-        <p:spPr>
-          <a:xfrm>
-            <a:off x="713232" y="3063240"/>
-            <a:ext cx="2240280" cy="548640"/>
-          </a:xfrm>
-          <a:prstGeom prst="rect">
-            <a:avLst/>
-          </a:prstGeom>
-          <a:noFill/>
-          <a:ln/>
-        </p:spPr>
-        <p:txBody>
-          <a:bodyPr wrap="square" lIns="0" tIns="0" rIns="0" bIns="0" rtlCol="0" anchor="t"/>
-          <a:lstStyle/>
-          <a:p>
-            <a:pPr marL="0" indent="0">
-              <a:buNone/>
-            </a:pPr>
-            <a:r>
-              <a:rPr lang="en-US" sz="850" b="1" kern="0" spc="200" dirty="0">
-                <a:solidFill>
-                  <a:srgbClr val="E6F6EE"/>
-                </a:solidFill>
-                <a:latin typeface="Calibri" pitchFamily="34" charset="0"/>
-                <a:ea typeface="Calibri" pitchFamily="34" charset="-122"/>
-                <a:cs typeface="Calibri" pitchFamily="34" charset="-120"/>
-              </a:rPr>
-              <a:t>HANDS-ON LAB</a:t>
-            </a:r>
-            <a:endParaRPr lang="en-US" sz="1100" dirty="0"/>
-          </a:p>
-          <a:p>
-            <a:pPr marL="0" indent="0">
-              <a:buNone/>
-            </a:pPr>
-            <a:r>
-              <a:rPr lang="en-US" sz="1150" b="1" dirty="0">
-                <a:solidFill>
-                  <a:srgbClr val="FFFFFF"/>
-                </a:solidFill>
-                <a:latin typeface="Calibri" pitchFamily="34" charset="0"/>
-                <a:ea typeface="Calibri" pitchFamily="34" charset="-122"/>
-                <a:cs typeface="Calibri" pitchFamily="34" charset="-120"/>
-              </a:rPr>
-              <a:t>Retrieval-augmented generation (RAG)</a:t>
-            </a:r>
-            <a:endParaRPr lang="en-US" sz="1100" dirty="0"/>
-          </a:p>
-        </p:txBody>
-      </p:sp>
-      <p:sp>
-        <p:nvSpPr>
-          <p:cNvPr id="9" name="Shape 6"/>
-          <p:cNvSpPr/>
-          <p:nvPr/>
-        </p:nvSpPr>
-        <p:spPr>
-          <a:xfrm>
-            <a:off x="3246120" y="2514600"/>
-            <a:ext cx="2514600" cy="1143000"/>
-          </a:xfrm>
-          <a:prstGeom prst="roundRect">
-            <a:avLst>
-              <a:gd name="adj" fmla="val 6400"/>
-            </a:avLst>
-          </a:prstGeom>
-          <a:solidFill>
-            <a:srgbClr val="FFFFFF">
-              <a:alpha val="12000"/>
-            </a:srgbClr>
-          </a:solidFill>
-          <a:ln w="9525">
-            <a:solidFill>
-              <a:srgbClr val="FFFFFF">
-                <a:alpha val="50000"/>
-              </a:srgbClr>
-            </a:solidFill>
-            <a:prstDash val="solid"/>
-          </a:ln>
-        </p:spPr>
-      </p:sp>
-      <p:pic>
-        <p:nvPicPr>
-          <p:cNvPr id="10" name="Image 1" descr="preencoded.png"/>
-          <p:cNvPicPr>
-            <a:picLocks noChangeAspect="1"/>
-          </p:cNvPicPr>
-          <p:nvPr/>
-        </p:nvPicPr>
-        <p:blipFill>
-          <a:blip r:embed="rId5"/>
-          <a:stretch>
-            <a:fillRect/>
-          </a:stretch>
-        </p:blipFill>
-        <p:spPr>
-          <a:xfrm>
-            <a:off x="3410712" y="2670048"/>
-            <a:ext cx="310896" cy="310896"/>
-          </a:xfrm>
-          <a:prstGeom prst="rect">
-            <a:avLst/>
-          </a:prstGeom>
-        </p:spPr>
-      </p:pic>
-      <p:sp>
-        <p:nvSpPr>
-          <p:cNvPr id="11" name="Text 7"/>
-          <p:cNvSpPr txBox="1"/>
-          <p:nvPr/>
-        </p:nvSpPr>
-        <p:spPr>
-          <a:xfrm>
-            <a:off x="3813048" y="2651760"/>
-            <a:ext cx="1737360" cy="347472"/>
-          </a:xfrm>
-          <a:prstGeom prst="rect">
-            <a:avLst/>
-          </a:prstGeom>
-          <a:noFill/>
-          <a:ln/>
-        </p:spPr>
-        <p:txBody>
-          <a:bodyPr wrap="square" lIns="0" tIns="0" rIns="0" bIns="0" rtlCol="0" anchor="ctr"/>
-          <a:lstStyle/>
-          <a:p>
-            <a:pPr marL="0" indent="0">
-              <a:buNone/>
-            </a:pPr>
-            <a:r>
-              <a:rPr lang="en-US" sz="2000" b="1" dirty="0">
-                <a:solidFill>
-                  <a:srgbClr val="F5C242"/>
-                </a:solidFill>
-                <a:latin typeface="Calibri" pitchFamily="34" charset="0"/>
-                <a:ea typeface="Calibri" pitchFamily="34" charset="-122"/>
-                <a:cs typeface="Calibri" pitchFamily="34" charset="-120"/>
-              </a:rPr>
-              <a:t>13:30</a:t>
-            </a:r>
-            <a:endParaRPr lang="en-US" sz="2000" dirty="0"/>
-          </a:p>
-        </p:txBody>
-      </p:sp>
-      <p:sp>
-        <p:nvSpPr>
-          <p:cNvPr id="12" name="Text 8"/>
-          <p:cNvSpPr txBox="1"/>
-          <p:nvPr/>
-        </p:nvSpPr>
-        <p:spPr>
-          <a:xfrm>
-            <a:off x="3410712" y="3063240"/>
-            <a:ext cx="2240280" cy="548640"/>
-          </a:xfrm>
-          <a:prstGeom prst="rect">
-            <a:avLst/>
-          </a:prstGeom>
-          <a:noFill/>
-          <a:ln/>
-        </p:spPr>
-        <p:txBody>
-          <a:bodyPr wrap="square" lIns="0" tIns="0" rIns="0" bIns="0" rtlCol="0" anchor="t"/>
-          <a:lstStyle/>
-          <a:p>
-            <a:pPr marL="0" indent="0">
-              <a:buNone/>
-            </a:pPr>
-            <a:r>
-              <a:rPr lang="en-US" sz="850" b="1" kern="0" spc="200" dirty="0">
-                <a:solidFill>
-                  <a:srgbClr val="E6F6EE"/>
-                </a:solidFill>
-                <a:latin typeface="Calibri" pitchFamily="34" charset="0"/>
-                <a:ea typeface="Calibri" pitchFamily="34" charset="-122"/>
-                <a:cs typeface="Calibri" pitchFamily="34" charset="-120"/>
-              </a:rPr>
-              <a:t>TALK</a:t>
-            </a:r>
-            <a:endParaRPr lang="en-US" sz="1100" dirty="0"/>
-          </a:p>
-          <a:p>
-            <a:pPr marL="0" indent="0">
-              <a:buNone/>
-            </a:pPr>
-            <a:r>
-              <a:rPr lang="en-US" sz="1150" b="1" dirty="0">
-                <a:solidFill>
-                  <a:srgbClr val="FFFFFF"/>
-                </a:solidFill>
-                <a:latin typeface="Calibri" pitchFamily="34" charset="0"/>
-                <a:ea typeface="Calibri" pitchFamily="34" charset="-122"/>
-                <a:cs typeface="Calibri" pitchFamily="34" charset="-120"/>
-              </a:rPr>
-              <a:t>AI infrastructure: what you really need</a:t>
-            </a:r>
-            <a:endParaRPr lang="en-US" sz="1100" dirty="0"/>
-          </a:p>
-        </p:txBody>
-      </p:sp>
-      <p:sp>
-        <p:nvSpPr>
-          <p:cNvPr id="13" name="Shape 9"/>
-          <p:cNvSpPr/>
-          <p:nvPr/>
-        </p:nvSpPr>
-        <p:spPr>
-          <a:xfrm>
-            <a:off x="5943600" y="2514600"/>
-            <a:ext cx="2514600" cy="1143000"/>
-          </a:xfrm>
-          <a:prstGeom prst="roundRect">
-            <a:avLst>
-              <a:gd name="adj" fmla="val 6400"/>
-            </a:avLst>
-          </a:prstGeom>
-          <a:solidFill>
-            <a:srgbClr val="FFFFFF">
-              <a:alpha val="12000"/>
-            </a:srgbClr>
-          </a:solidFill>
-          <a:ln w="9525">
-            <a:solidFill>
-              <a:srgbClr val="FFFFFF">
-                <a:alpha val="50000"/>
-              </a:srgbClr>
-            </a:solidFill>
-            <a:prstDash val="solid"/>
-          </a:ln>
-        </p:spPr>
-      </p:sp>
-      <p:pic>
-        <p:nvPicPr>
-          <p:cNvPr id="14" name="Image 2" descr="preencoded.png"/>
-          <p:cNvPicPr>
-            <a:picLocks noChangeAspect="1"/>
-          </p:cNvPicPr>
-          <p:nvPr/>
-        </p:nvPicPr>
-        <p:blipFill>
-          <a:blip r:embed="rId6"/>
-          <a:stretch>
-            <a:fillRect/>
-          </a:stretch>
-        </p:blipFill>
-        <p:spPr>
-          <a:xfrm>
-            <a:off x="6108192" y="2670048"/>
-            <a:ext cx="310896" cy="310896"/>
-          </a:xfrm>
-          <a:prstGeom prst="rect">
-            <a:avLst/>
-          </a:prstGeom>
-        </p:spPr>
-      </p:pic>
-      <p:sp>
-        <p:nvSpPr>
-          <p:cNvPr id="15" name="Text 10"/>
-          <p:cNvSpPr txBox="1"/>
-          <p:nvPr/>
-        </p:nvSpPr>
-        <p:spPr>
-          <a:xfrm>
-            <a:off x="6510528" y="2651760"/>
-            <a:ext cx="1737360" cy="347472"/>
-          </a:xfrm>
-          <a:prstGeom prst="rect">
-            <a:avLst/>
-          </a:prstGeom>
-          <a:noFill/>
-          <a:ln/>
-        </p:spPr>
-        <p:txBody>
-          <a:bodyPr wrap="square" lIns="0" tIns="0" rIns="0" bIns="0" rtlCol="0" anchor="ctr"/>
-          <a:lstStyle/>
-          <a:p>
-            <a:pPr marL="0" indent="0">
-              <a:buNone/>
-            </a:pPr>
-            <a:r>
-              <a:rPr lang="en-US" sz="2000" b="1" dirty="0">
-                <a:solidFill>
-                  <a:srgbClr val="F5C242"/>
-                </a:solidFill>
-                <a:latin typeface="Calibri" pitchFamily="34" charset="0"/>
-                <a:ea typeface="Calibri" pitchFamily="34" charset="-122"/>
-                <a:cs typeface="Calibri" pitchFamily="34" charset="-120"/>
-              </a:rPr>
-              <a:t>15:00</a:t>
-            </a:r>
-            <a:endParaRPr lang="en-US" sz="2000" dirty="0"/>
-          </a:p>
-        </p:txBody>
-      </p:sp>
-      <p:sp>
-        <p:nvSpPr>
-          <p:cNvPr id="16" name="Text 11"/>
-          <p:cNvSpPr txBox="1"/>
-          <p:nvPr/>
-        </p:nvSpPr>
-        <p:spPr>
-          <a:xfrm>
-            <a:off x="6108192" y="3063240"/>
-            <a:ext cx="2240280" cy="548640"/>
-          </a:xfrm>
-          <a:prstGeom prst="rect">
-            <a:avLst/>
-          </a:prstGeom>
-          <a:noFill/>
-          <a:ln/>
-        </p:spPr>
-        <p:txBody>
-          <a:bodyPr wrap="square" lIns="0" tIns="0" rIns="0" bIns="0" rtlCol="0" anchor="t"/>
-          <a:lstStyle/>
-          <a:p>
-            <a:pPr marL="0" indent="0">
-              <a:buNone/>
-            </a:pPr>
-            <a:r>
-              <a:rPr lang="en-US" sz="850" b="1" kern="0" spc="200" dirty="0">
-                <a:solidFill>
-                  <a:srgbClr val="E6F6EE"/>
-                </a:solidFill>
-                <a:latin typeface="Calibri" pitchFamily="34" charset="0"/>
-                <a:ea typeface="Calibri" pitchFamily="34" charset="-122"/>
-                <a:cs typeface="Calibri" pitchFamily="34" charset="-120"/>
-              </a:rPr>
-              <a:t>HANDS-ON LAB</a:t>
-            </a:r>
-            <a:endParaRPr lang="en-US" sz="1100" dirty="0"/>
-          </a:p>
-          <a:p>
-            <a:pPr marL="0" indent="0">
-              <a:buNone/>
-            </a:pPr>
-            <a:r>
-              <a:rPr lang="en-US" sz="1150" b="1" dirty="0">
-                <a:solidFill>
-                  <a:srgbClr val="FFFFFF"/>
-                </a:solidFill>
-                <a:latin typeface="Calibri" pitchFamily="34" charset="0"/>
-                <a:ea typeface="Calibri" pitchFamily="34" charset="-122"/>
-                <a:cs typeface="Calibri" pitchFamily="34" charset="-120"/>
-              </a:rPr>
-              <a:t>Build an agent, then break it</a:t>
-            </a:r>
-            <a:endParaRPr lang="en-US" sz="1100" dirty="0"/>
-          </a:p>
-        </p:txBody>
-      </p:sp>
-      <p:pic>
-        <p:nvPicPr>
-          <p:cNvPr id="17" name="Image 3" descr="preencoded.png"/>
-          <p:cNvPicPr>
-            <a:picLocks noChangeAspect="1"/>
-          </p:cNvPicPr>
-          <p:nvPr/>
-        </p:nvPicPr>
-        <p:blipFill>
-          <a:blip r:embed="rId7"/>
-          <a:stretch>
-            <a:fillRect/>
-          </a:stretch>
-        </p:blipFill>
-        <p:spPr>
-          <a:xfrm>
-            <a:off x="548640" y="3977640"/>
-            <a:ext cx="274320" cy="274320"/>
-          </a:xfrm>
-          <a:prstGeom prst="rect">
-            <a:avLst/>
-          </a:prstGeom>
-        </p:spPr>
-      </p:pic>
-      <p:sp>
-        <p:nvSpPr>
-          <p:cNvPr id="18" name="Text 12"/>
-          <p:cNvSpPr txBox="1"/>
-          <p:nvPr/>
-        </p:nvSpPr>
-        <p:spPr>
-          <a:xfrm>
-            <a:off x="960120" y="3931920"/>
-            <a:ext cx="7315200" cy="365760"/>
-          </a:xfrm>
-          <a:prstGeom prst="rect">
-            <a:avLst/>
-          </a:prstGeom>
-          <a:noFill/>
-          <a:ln/>
-        </p:spPr>
-        <p:txBody>
-          <a:bodyPr wrap="square" lIns="0" tIns="0" rIns="0" bIns="0" rtlCol="0" anchor="ctr"/>
-          <a:lstStyle/>
-          <a:p>
-            <a:pPr marL="0" indent="0">
-              <a:buNone/>
-            </a:pPr>
-            <a:r>
-              <a:rPr lang="en-US" sz="1300" b="1" dirty="0">
-                <a:solidFill>
-                  <a:srgbClr val="FFFFFF"/>
-                </a:solidFill>
-                <a:latin typeface="Calibri" pitchFamily="34" charset="0"/>
-                <a:ea typeface="Calibri" pitchFamily="34" charset="-122"/>
-                <a:cs typeface="Calibri" pitchFamily="34" charset="-120"/>
-              </a:rPr>
-              <a:t>Bring: a real question from your office that a document could answer.</a:t>
-            </a:r>
-            <a:endParaRPr lang="en-US" sz="1300" dirty="0"/>
-          </a:p>
-        </p:txBody>
-      </p:sp>
-    </p:spTree>
-  </p:cSld>
-  <p:clrMapOvr>
-    <a:masterClrMapping/>
-  </p:clrMapOvr>
-  <p:transition spd="med">
-    <p:fade/>
-  </p:transition>
-</p:sld>
-</file>
-
-<file path=ppt/slides/slide32.xml><?xml version="1.0" encoding="utf-8"?>
-<p:sld xmlns:a="http://schemas.openxmlformats.org/drawingml/2006/main" xmlns:r="http://schemas.openxmlformats.org/officeDocument/2006/relationships" xmlns:p="http://schemas.openxmlformats.org/presentationml/2006/main">
   <p:cSld name="Slide 32">
     <p:bg>
       <p:bgPr>
@@ -35555,7 +34707,7 @@
 </p:sld>
 </file>
 
-<file path=ppt/slides/slide33.xml><?xml version="1.0" encoding="utf-8"?>
+<file path=ppt/slides/slide32.xml><?xml version="1.0" encoding="utf-8"?>
 <p:sld xmlns:a="http://schemas.openxmlformats.org/drawingml/2006/main" xmlns:r="http://schemas.openxmlformats.org/officeDocument/2006/relationships" xmlns:p="http://schemas.openxmlformats.org/presentationml/2006/main">
   <p:cSld name="Slide 33">
     <p:bg>
@@ -37539,7 +36691,7 @@
 </p:sld>
 </file>
 
-<file path=ppt/slides/slide34.xml><?xml version="1.0" encoding="utf-8"?>
+<file path=ppt/slides/slide33.xml><?xml version="1.0" encoding="utf-8"?>
 <p:sld xmlns:a="http://schemas.openxmlformats.org/drawingml/2006/main" xmlns:r="http://schemas.openxmlformats.org/officeDocument/2006/relationships" xmlns:p="http://schemas.openxmlformats.org/presentationml/2006/main">
   <p:cSld name="Slide 34">
     <p:bg>
@@ -38526,7 +37678,7 @@
 </p:sld>
 </file>
 
-<file path=ppt/slides/slide35.xml><?xml version="1.0" encoding="utf-8"?>
+<file path=ppt/slides/slide34.xml><?xml version="1.0" encoding="utf-8"?>
 <p:sld xmlns:a="http://schemas.openxmlformats.org/drawingml/2006/main" xmlns:r="http://schemas.openxmlformats.org/officeDocument/2006/relationships" xmlns:p="http://schemas.openxmlformats.org/presentationml/2006/main">
   <p:cSld name="Slide 35">
     <p:bg>
@@ -39438,733 +38590,7 @@
 </p:sld>
 </file>
 
-<file path=ppt/slides/slide36.xml><?xml version="1.0" encoding="utf-8"?>
-<p:sld xmlns:a="http://schemas.openxmlformats.org/drawingml/2006/main" xmlns:r="http://schemas.openxmlformats.org/officeDocument/2006/relationships" xmlns:p="http://schemas.openxmlformats.org/presentationml/2006/main">
-  <p:cSld name="Slide 36">
-    <p:bg>
-      <p:bgPr>
-        <a:solidFill>
-          <a:srgbClr val="FFFFFF"/>
-        </a:solidFill>
-        <a:effectLst/>
-      </p:bgPr>
-    </p:bg>
-    <p:spTree>
-      <p:nvGrpSpPr>
-        <p:cNvPr id="1" name=""/>
-        <p:cNvGrpSpPr/>
-        <p:nvPr/>
-      </p:nvGrpSpPr>
-      <p:grpSpPr>
-        <a:xfrm>
-          <a:off x="0" y="0"/>
-          <a:ext cx="0" cy="0"/>
-          <a:chOff x="0" y="0"/>
-          <a:chExt cx="0" cy="0"/>
-        </a:xfrm>
-      </p:grpSpPr>
-      <p:sp>
-        <p:nvSpPr>
-          <p:cNvPr id="2" name="Shape 0"/>
-          <p:cNvSpPr/>
-          <p:nvPr/>
-        </p:nvSpPr>
-        <p:spPr>
-          <a:xfrm>
-            <a:off x="0" y="0"/>
-            <a:ext cx="9144000" cy="54864"/>
-          </a:xfrm>
-          <a:prstGeom prst="rect">
-            <a:avLst/>
-          </a:prstGeom>
-          <a:solidFill>
-            <a:srgbClr val="00A86A"/>
-          </a:solidFill>
-          <a:ln/>
-        </p:spPr>
-      </p:sp>
-      <p:sp>
-        <p:nvSpPr>
-          <p:cNvPr id="3" name="Shape 1"/>
-          <p:cNvSpPr/>
-          <p:nvPr/>
-        </p:nvSpPr>
-        <p:spPr>
-          <a:xfrm>
-            <a:off x="0" y="0"/>
-            <a:ext cx="1234440" cy="54864"/>
-          </a:xfrm>
-          <a:prstGeom prst="rect">
-            <a:avLst/>
-          </a:prstGeom>
-          <a:solidFill>
-            <a:srgbClr val="F5C242"/>
-          </a:solidFill>
-          <a:ln/>
-        </p:spPr>
-      </p:sp>
-      <p:sp>
-        <p:nvSpPr>
-          <p:cNvPr id="4" name="Shape 2"/>
-          <p:cNvSpPr/>
-          <p:nvPr/>
-        </p:nvSpPr>
-        <p:spPr>
-          <a:xfrm>
-            <a:off x="7406640" y="3383280"/>
-            <a:ext cx="2743200" cy="2743200"/>
-          </a:xfrm>
-          <a:prstGeom prst="ellipse">
-            <a:avLst/>
-          </a:prstGeom>
-          <a:solidFill>
-            <a:srgbClr val="00A86A">
-              <a:alpha val="5000"/>
-            </a:srgbClr>
-          </a:solidFill>
-          <a:ln/>
-        </p:spPr>
-      </p:sp>
-      <p:sp>
-        <p:nvSpPr>
-          <p:cNvPr id="5" name="Shape 3"/>
-          <p:cNvSpPr/>
-          <p:nvPr/>
-        </p:nvSpPr>
-        <p:spPr>
-          <a:xfrm>
-            <a:off x="7955280" y="3931920"/>
-            <a:ext cx="1645920" cy="1645920"/>
-          </a:xfrm>
-          <a:prstGeom prst="ellipse">
-            <a:avLst/>
-          </a:prstGeom>
-          <a:solidFill>
-            <a:srgbClr val="00A86A">
-              <a:alpha val="5000"/>
-            </a:srgbClr>
-          </a:solidFill>
-          <a:ln/>
-        </p:spPr>
-      </p:sp>
-      <p:sp>
-        <p:nvSpPr>
-          <p:cNvPr id="6" name="Text 4"/>
-          <p:cNvSpPr txBox="1"/>
-          <p:nvPr/>
-        </p:nvSpPr>
-        <p:spPr>
-          <a:xfrm>
-            <a:off x="457200" y="274320"/>
-            <a:ext cx="6858000" cy="201168"/>
-          </a:xfrm>
-          <a:prstGeom prst="rect">
-            <a:avLst/>
-          </a:prstGeom>
-          <a:noFill/>
-          <a:ln/>
-        </p:spPr>
-        <p:txBody>
-          <a:bodyPr wrap="square" lIns="0" tIns="0" rIns="0" bIns="0" rtlCol="0" anchor="t"/>
-          <a:lstStyle/>
-          <a:p>
-            <a:pPr marL="0" indent="0">
-              <a:buNone/>
-            </a:pPr>
-            <a:r>
-              <a:rPr lang="en-US" sz="1050" b="1" kern="0" spc="150" dirty="0">
-                <a:solidFill>
-                  <a:srgbClr val="00704A"/>
-                </a:solidFill>
-                <a:latin typeface="Calibri" pitchFamily="34" charset="0"/>
-                <a:ea typeface="Calibri" pitchFamily="34" charset="-122"/>
-                <a:cs typeface="Calibri" pitchFamily="34" charset="-120"/>
-              </a:rPr>
-              <a:t>APPENDIX  ·  THE COST OF PRE-TRAINING</a:t>
-            </a:r>
-            <a:endParaRPr lang="en-US" sz="1050" dirty="0"/>
-          </a:p>
-        </p:txBody>
-      </p:sp>
-      <p:sp>
-        <p:nvSpPr>
-          <p:cNvPr id="7" name="Text 5"/>
-          <p:cNvSpPr txBox="1"/>
-          <p:nvPr/>
-        </p:nvSpPr>
-        <p:spPr>
-          <a:xfrm>
-            <a:off x="457200" y="475488"/>
-            <a:ext cx="7498080" cy="749808"/>
-          </a:xfrm>
-          <a:prstGeom prst="rect">
-            <a:avLst/>
-          </a:prstGeom>
-          <a:noFill/>
-          <a:ln/>
-        </p:spPr>
-        <p:txBody>
-          <a:bodyPr wrap="square" lIns="0" tIns="0" rIns="0" bIns="0" rtlCol="0" anchor="ctr"/>
-          <a:lstStyle/>
-          <a:p>
-            <a:pPr marL="0" indent="0">
-              <a:buNone/>
-            </a:pPr>
-            <a:r>
-              <a:rPr lang="en-US" sz="2800" b="1" dirty="0">
-                <a:solidFill>
-                  <a:srgbClr val="231F20"/>
-                </a:solidFill>
-                <a:latin typeface="Calibri" pitchFamily="34" charset="0"/>
-                <a:ea typeface="Calibri" pitchFamily="34" charset="-122"/>
-                <a:cs typeface="Calibri" pitchFamily="34" charset="-120"/>
-              </a:rPr>
-              <a:t>Why an NSO will not pre-train its own LLM</a:t>
-            </a:r>
-            <a:endParaRPr lang="en-US" sz="2800" dirty="0"/>
-          </a:p>
-        </p:txBody>
-      </p:sp>
-      <p:sp>
-        <p:nvSpPr>
-          <p:cNvPr id="8" name="Text 6"/>
-          <p:cNvSpPr txBox="1"/>
-          <p:nvPr/>
-        </p:nvSpPr>
-        <p:spPr>
-          <a:xfrm>
-            <a:off x="457200" y="4846320"/>
-            <a:ext cx="4572000" cy="182880"/>
-          </a:xfrm>
-          <a:prstGeom prst="rect">
-            <a:avLst/>
-          </a:prstGeom>
-          <a:noFill/>
-          <a:ln/>
-        </p:spPr>
-        <p:txBody>
-          <a:bodyPr wrap="square" lIns="0" tIns="0" rIns="0" bIns="0" rtlCol="0" anchor="t"/>
-          <a:lstStyle/>
-          <a:p>
-            <a:pPr marL="0" indent="0">
-              <a:buNone/>
-            </a:pPr>
-            <a:r>
-              <a:rPr lang="en-US" sz="850" dirty="0">
-                <a:solidFill>
-                  <a:srgbClr val="8A9590"/>
-                </a:solidFill>
-                <a:latin typeface="Calibri" pitchFamily="34" charset="0"/>
-                <a:ea typeface="Calibri" pitchFamily="34" charset="-122"/>
-                <a:cs typeface="Calibri" pitchFamily="34" charset="-120"/>
-              </a:rPr>
-              <a:t>The AI Family Tree  ·  STG17</a:t>
-            </a:r>
-            <a:endParaRPr lang="en-US" sz="850" dirty="0"/>
-          </a:p>
-        </p:txBody>
-      </p:sp>
-      <p:sp>
-        <p:nvSpPr>
-          <p:cNvPr id="9" name="Text 7"/>
-          <p:cNvSpPr txBox="1"/>
-          <p:nvPr/>
-        </p:nvSpPr>
-        <p:spPr>
-          <a:xfrm>
-            <a:off x="7772400" y="4846320"/>
-            <a:ext cx="914400" cy="182880"/>
-          </a:xfrm>
-          <a:prstGeom prst="rect">
-            <a:avLst/>
-          </a:prstGeom>
-          <a:noFill/>
-          <a:ln/>
-        </p:spPr>
-        <p:txBody>
-          <a:bodyPr wrap="square" lIns="0" tIns="0" rIns="0" bIns="0" rtlCol="0" anchor="t"/>
-          <a:lstStyle/>
-          <a:p>
-            <a:pPr marL="0" indent="0" algn="r">
-              <a:buNone/>
-            </a:pPr>
-            <a:r>
-              <a:rPr lang="en-US" sz="850" dirty="0">
-                <a:solidFill>
-                  <a:srgbClr val="8A9590"/>
-                </a:solidFill>
-                <a:latin typeface="Calibri" pitchFamily="34" charset="0"/>
-                <a:ea typeface="Calibri" pitchFamily="34" charset="-122"/>
-                <a:cs typeface="Calibri" pitchFamily="34" charset="-120"/>
-              </a:rPr>
-              <a:t>36</a:t>
-            </a:r>
-            <a:endParaRPr lang="en-US" sz="850" dirty="0"/>
-          </a:p>
-        </p:txBody>
-      </p:sp>
-      <p:sp>
-        <p:nvSpPr>
-          <p:cNvPr id="10" name="Shape 8"/>
-          <p:cNvSpPr/>
-          <p:nvPr/>
-        </p:nvSpPr>
-        <p:spPr>
-          <a:xfrm>
-            <a:off x="457200" y="1371600"/>
-            <a:ext cx="3474720" cy="2834640"/>
-          </a:xfrm>
-          <a:prstGeom prst="roundRect">
-            <a:avLst>
-              <a:gd name="adj" fmla="val 2581"/>
-            </a:avLst>
-          </a:prstGeom>
-          <a:solidFill>
-            <a:srgbClr val="E8F5EF"/>
-          </a:solidFill>
-          <a:ln w="15875">
-            <a:solidFill>
-              <a:srgbClr val="00A86A"/>
-            </a:solidFill>
-            <a:prstDash val="solid"/>
-          </a:ln>
-        </p:spPr>
-      </p:sp>
-      <p:sp>
-        <p:nvSpPr>
-          <p:cNvPr id="11" name="Text 9"/>
-          <p:cNvSpPr txBox="1"/>
-          <p:nvPr/>
-        </p:nvSpPr>
-        <p:spPr>
-          <a:xfrm>
-            <a:off x="640080" y="1600200"/>
-            <a:ext cx="3108960" cy="1005840"/>
-          </a:xfrm>
-          <a:prstGeom prst="rect">
-            <a:avLst/>
-          </a:prstGeom>
-          <a:noFill/>
-          <a:ln/>
-        </p:spPr>
-        <p:txBody>
-          <a:bodyPr wrap="square" lIns="0" tIns="0" rIns="0" bIns="0" rtlCol="0" anchor="ctr"/>
-          <a:lstStyle/>
-          <a:p>
-            <a:pPr marL="0" indent="0" algn="ctr">
-              <a:buNone/>
-            </a:pPr>
-            <a:r>
-              <a:rPr lang="en-US" sz="6000" b="1" dirty="0">
-                <a:solidFill>
-                  <a:srgbClr val="00A86A"/>
-                </a:solidFill>
-                <a:latin typeface="Calibri" pitchFamily="34" charset="0"/>
-                <a:ea typeface="Calibri" pitchFamily="34" charset="-122"/>
-                <a:cs typeface="Calibri" pitchFamily="34" charset="-120"/>
-              </a:rPr>
-              <a:t>20 : 1</a:t>
-            </a:r>
-            <a:endParaRPr lang="en-US" sz="6000" dirty="0"/>
-          </a:p>
-        </p:txBody>
-      </p:sp>
-      <p:sp>
-        <p:nvSpPr>
-          <p:cNvPr id="12" name="Text 10"/>
-          <p:cNvSpPr txBox="1"/>
-          <p:nvPr/>
-        </p:nvSpPr>
-        <p:spPr>
-          <a:xfrm>
-            <a:off x="731520" y="2697480"/>
-            <a:ext cx="2926080" cy="640080"/>
-          </a:xfrm>
-          <a:prstGeom prst="rect">
-            <a:avLst/>
-          </a:prstGeom>
-          <a:noFill/>
-          <a:ln/>
-        </p:spPr>
-        <p:txBody>
-          <a:bodyPr wrap="square" lIns="0" tIns="0" rIns="0" bIns="0" rtlCol="0" anchor="t"/>
-          <a:lstStyle/>
-          <a:p>
-            <a:pPr marL="0" indent="0" algn="ctr">
-              <a:buNone/>
-            </a:pPr>
-            <a:r>
-              <a:rPr lang="en-US" sz="1250" dirty="0">
-                <a:solidFill>
-                  <a:srgbClr val="5E6964"/>
-                </a:solidFill>
-                <a:latin typeface="Calibri" pitchFamily="34" charset="0"/>
-                <a:ea typeface="Calibri" pitchFamily="34" charset="-122"/>
-                <a:cs typeface="Calibri" pitchFamily="34" charset="-120"/>
-              </a:rPr>
-              <a:t>training tokens per parameter for a compute-optimal model</a:t>
-            </a:r>
-            <a:endParaRPr lang="en-US" sz="1250" dirty="0"/>
-          </a:p>
-        </p:txBody>
-      </p:sp>
-      <p:sp>
-        <p:nvSpPr>
-          <p:cNvPr id="13" name="Shape 11"/>
-          <p:cNvSpPr/>
-          <p:nvPr/>
-        </p:nvSpPr>
-        <p:spPr>
-          <a:xfrm>
-            <a:off x="4206240" y="1417320"/>
-            <a:ext cx="457200" cy="457200"/>
-          </a:xfrm>
-          <a:prstGeom prst="ellipse">
-            <a:avLst/>
-          </a:prstGeom>
-          <a:solidFill>
-            <a:srgbClr val="00704A">
-              <a:alpha val="22000"/>
-            </a:srgbClr>
-          </a:solidFill>
-          <a:ln/>
-        </p:spPr>
-      </p:sp>
-      <p:pic>
-        <p:nvPicPr>
-          <p:cNvPr id="14" name="Image 0" descr="preencoded.png"/>
-          <p:cNvPicPr>
-            <a:picLocks noChangeAspect="1"/>
-          </p:cNvPicPr>
-          <p:nvPr/>
-        </p:nvPicPr>
-        <p:blipFill>
-          <a:blip r:embed="rId3"/>
-          <a:stretch>
-            <a:fillRect/>
-          </a:stretch>
-        </p:blipFill>
-        <p:spPr>
-          <a:xfrm>
-            <a:off x="4315968" y="1527048"/>
-            <a:ext cx="237744" cy="237744"/>
-          </a:xfrm>
-          <a:prstGeom prst="rect">
-            <a:avLst/>
-          </a:prstGeom>
-        </p:spPr>
-      </p:pic>
-      <p:sp>
-        <p:nvSpPr>
-          <p:cNvPr id="15" name="Text 12"/>
-          <p:cNvSpPr txBox="1"/>
-          <p:nvPr/>
-        </p:nvSpPr>
-        <p:spPr>
-          <a:xfrm>
-            <a:off x="4800600" y="1371600"/>
-            <a:ext cx="3886200" cy="868680"/>
-          </a:xfrm>
-          <a:prstGeom prst="rect">
-            <a:avLst/>
-          </a:prstGeom>
-          <a:noFill/>
-          <a:ln/>
-        </p:spPr>
-        <p:txBody>
-          <a:bodyPr wrap="square" lIns="0" tIns="0" rIns="0" bIns="0" rtlCol="0" anchor="t"/>
-          <a:lstStyle/>
-          <a:p>
-            <a:pPr marL="0" indent="0">
-              <a:buNone/>
-            </a:pPr>
-            <a:r>
-              <a:rPr lang="en-US" sz="1250" b="1" dirty="0">
-                <a:solidFill>
-                  <a:srgbClr val="00704A"/>
-                </a:solidFill>
-                <a:latin typeface="Calibri" pitchFamily="34" charset="0"/>
-                <a:ea typeface="Calibri" pitchFamily="34" charset="-122"/>
-                <a:cs typeface="Calibri" pitchFamily="34" charset="-120"/>
-              </a:rPr>
-              <a:t>An order of magnitude</a:t>
-            </a:r>
-            <a:endParaRPr lang="en-US" sz="1100" dirty="0"/>
-          </a:p>
-          <a:p>
-            <a:pPr marL="0" indent="0">
-              <a:buNone/>
-            </a:pPr>
-            <a:r>
-              <a:rPr lang="en-US" sz="1100" dirty="0">
-                <a:solidFill>
-                  <a:srgbClr val="231F20"/>
-                </a:solidFill>
-                <a:latin typeface="Calibri" pitchFamily="34" charset="0"/>
-                <a:ea typeface="Calibri" pitchFamily="34" charset="-122"/>
-                <a:cs typeface="Calibri" pitchFamily="34" charset="-120"/>
-              </a:rPr>
-              <a:t>At the scale of the models used this week, that means a corpus and a compute budget no NSO will assemble — nor should.</a:t>
-            </a:r>
-            <a:endParaRPr lang="en-US" sz="1100" dirty="0"/>
-          </a:p>
-        </p:txBody>
-      </p:sp>
-      <p:sp>
-        <p:nvSpPr>
-          <p:cNvPr id="16" name="Shape 13"/>
-          <p:cNvSpPr/>
-          <p:nvPr/>
-        </p:nvSpPr>
-        <p:spPr>
-          <a:xfrm>
-            <a:off x="4206240" y="2377440"/>
-            <a:ext cx="457200" cy="457200"/>
-          </a:xfrm>
-          <a:prstGeom prst="ellipse">
-            <a:avLst/>
-          </a:prstGeom>
-          <a:solidFill>
-            <a:srgbClr val="D49A00">
-              <a:alpha val="22000"/>
-            </a:srgbClr>
-          </a:solidFill>
-          <a:ln/>
-        </p:spPr>
-      </p:sp>
-      <p:pic>
-        <p:nvPicPr>
-          <p:cNvPr id="17" name="Image 1" descr="preencoded.png"/>
-          <p:cNvPicPr>
-            <a:picLocks noChangeAspect="1"/>
-          </p:cNvPicPr>
-          <p:nvPr/>
-        </p:nvPicPr>
-        <p:blipFill>
-          <a:blip r:embed="rId4"/>
-          <a:stretch>
-            <a:fillRect/>
-          </a:stretch>
-        </p:blipFill>
-        <p:spPr>
-          <a:xfrm>
-            <a:off x="4315968" y="2487168"/>
-            <a:ext cx="237744" cy="237744"/>
-          </a:xfrm>
-          <a:prstGeom prst="rect">
-            <a:avLst/>
-          </a:prstGeom>
-        </p:spPr>
-      </p:pic>
-      <p:sp>
-        <p:nvSpPr>
-          <p:cNvPr id="18" name="Text 14"/>
-          <p:cNvSpPr txBox="1"/>
-          <p:nvPr/>
-        </p:nvSpPr>
-        <p:spPr>
-          <a:xfrm>
-            <a:off x="4800600" y="2331720"/>
-            <a:ext cx="3886200" cy="868680"/>
-          </a:xfrm>
-          <a:prstGeom prst="rect">
-            <a:avLst/>
-          </a:prstGeom>
-          <a:noFill/>
-          <a:ln/>
-        </p:spPr>
-        <p:txBody>
-          <a:bodyPr wrap="square" lIns="0" tIns="0" rIns="0" bIns="0" rtlCol="0" anchor="t"/>
-          <a:lstStyle/>
-          <a:p>
-            <a:pPr marL="0" indent="0">
-              <a:buNone/>
-            </a:pPr>
-            <a:r>
-              <a:rPr lang="en-US" sz="1250" b="1" dirty="0">
-                <a:solidFill>
-                  <a:srgbClr val="D49A00"/>
-                </a:solidFill>
-                <a:latin typeface="Calibri" pitchFamily="34" charset="0"/>
-                <a:ea typeface="Calibri" pitchFamily="34" charset="-122"/>
-                <a:cs typeface="Calibri" pitchFamily="34" charset="-120"/>
-              </a:rPr>
-              <a:t>Don't confuse them</a:t>
-            </a:r>
-            <a:endParaRPr lang="en-US" sz="1100" dirty="0"/>
-          </a:p>
-          <a:p>
-            <a:pPr marL="0" indent="0">
-              <a:buNone/>
-            </a:pPr>
-            <a:r>
-              <a:rPr lang="en-US" sz="1100" dirty="0">
-                <a:solidFill>
-                  <a:srgbClr val="231F20"/>
-                </a:solidFill>
-                <a:latin typeface="Calibri" pitchFamily="34" charset="0"/>
-                <a:ea typeface="Calibri" pitchFamily="34" charset="-122"/>
-                <a:cs typeface="Calibri" pitchFamily="34" charset="-120"/>
-              </a:rPr>
-              <a:t>Pre-training (out of reach) and fine-tuning (accessible, e.g. with LoRA on a single GPU).</a:t>
-            </a:r>
-            <a:endParaRPr lang="en-US" sz="1100" dirty="0"/>
-          </a:p>
-        </p:txBody>
-      </p:sp>
-      <p:sp>
-        <p:nvSpPr>
-          <p:cNvPr id="19" name="Shape 15"/>
-          <p:cNvSpPr/>
-          <p:nvPr/>
-        </p:nvSpPr>
-        <p:spPr>
-          <a:xfrm>
-            <a:off x="4206240" y="3337560"/>
-            <a:ext cx="457200" cy="457200"/>
-          </a:xfrm>
-          <a:prstGeom prst="ellipse">
-            <a:avLst/>
-          </a:prstGeom>
-          <a:solidFill>
-            <a:srgbClr val="00A86A">
-              <a:alpha val="22000"/>
-            </a:srgbClr>
-          </a:solidFill>
-          <a:ln/>
-        </p:spPr>
-      </p:sp>
-      <p:pic>
-        <p:nvPicPr>
-          <p:cNvPr id="20" name="Image 2" descr="preencoded.png"/>
-          <p:cNvPicPr>
-            <a:picLocks noChangeAspect="1"/>
-          </p:cNvPicPr>
-          <p:nvPr/>
-        </p:nvPicPr>
-        <p:blipFill>
-          <a:blip r:embed="rId5"/>
-          <a:stretch>
-            <a:fillRect/>
-          </a:stretch>
-        </p:blipFill>
-        <p:spPr>
-          <a:xfrm>
-            <a:off x="4315968" y="3447288"/>
-            <a:ext cx="237744" cy="237744"/>
-          </a:xfrm>
-          <a:prstGeom prst="rect">
-            <a:avLst/>
-          </a:prstGeom>
-        </p:spPr>
-      </p:pic>
-      <p:sp>
-        <p:nvSpPr>
-          <p:cNvPr id="21" name="Text 16"/>
-          <p:cNvSpPr txBox="1"/>
-          <p:nvPr/>
-        </p:nvSpPr>
-        <p:spPr>
-          <a:xfrm>
-            <a:off x="4800600" y="3291840"/>
-            <a:ext cx="3886200" cy="868680"/>
-          </a:xfrm>
-          <a:prstGeom prst="rect">
-            <a:avLst/>
-          </a:prstGeom>
-          <a:noFill/>
-          <a:ln/>
-        </p:spPr>
-        <p:txBody>
-          <a:bodyPr wrap="square" lIns="0" tIns="0" rIns="0" bIns="0" rtlCol="0" anchor="t"/>
-          <a:lstStyle/>
-          <a:p>
-            <a:pPr marL="0" indent="0">
-              <a:buNone/>
-            </a:pPr>
-            <a:r>
-              <a:rPr lang="en-US" sz="1250" b="1" dirty="0">
-                <a:solidFill>
-                  <a:srgbClr val="00A86A"/>
-                </a:solidFill>
-                <a:latin typeface="Calibri" pitchFamily="34" charset="0"/>
-                <a:ea typeface="Calibri" pitchFamily="34" charset="-122"/>
-                <a:cs typeface="Calibri" pitchFamily="34" charset="-120"/>
-              </a:rPr>
-              <a:t>The real decision</a:t>
-            </a:r>
-            <a:endParaRPr lang="en-US" sz="1100" dirty="0"/>
-          </a:p>
-          <a:p>
-            <a:pPr marL="0" indent="0">
-              <a:buNone/>
-            </a:pPr>
-            <a:r>
-              <a:rPr lang="en-US" sz="1100" dirty="0">
-                <a:solidFill>
-                  <a:srgbClr val="231F20"/>
-                </a:solidFill>
-                <a:latin typeface="Calibri" pitchFamily="34" charset="0"/>
-                <a:ea typeface="Calibri" pitchFamily="34" charset="-122"/>
-                <a:cs typeface="Calibri" pitchFamily="34" charset="-120"/>
-              </a:rPr>
-              <a:t>Choosing, evaluating and governing an existing model — not building one.</a:t>
-            </a:r>
-            <a:endParaRPr lang="en-US" sz="1100" dirty="0"/>
-          </a:p>
-        </p:txBody>
-      </p:sp>
-      <p:sp>
-        <p:nvSpPr>
-          <p:cNvPr id="22" name="Text 17"/>
-          <p:cNvSpPr txBox="1"/>
-          <p:nvPr/>
-        </p:nvSpPr>
-        <p:spPr>
-          <a:xfrm>
-            <a:off x="457200" y="4590288"/>
-            <a:ext cx="8138160" cy="201168"/>
-          </a:xfrm>
-          <a:prstGeom prst="rect">
-            <a:avLst/>
-          </a:prstGeom>
-          <a:noFill/>
-          <a:ln/>
-        </p:spPr>
-        <p:txBody>
-          <a:bodyPr wrap="square" lIns="0" tIns="0" rIns="0" bIns="0" rtlCol="0" anchor="ctr"/>
-          <a:lstStyle/>
-          <a:p>
-            <a:pPr marL="0" indent="0">
-              <a:buNone/>
-            </a:pPr>
-            <a:r>
-              <a:rPr lang="en-US" sz="900" i="1" dirty="0">
-                <a:solidFill>
-                  <a:srgbClr val="5E6964"/>
-                </a:solidFill>
-                <a:latin typeface="Calibri" pitchFamily="34" charset="0"/>
-                <a:ea typeface="Calibri" pitchFamily="34" charset="-122"/>
-                <a:cs typeface="Calibri" pitchFamily="34" charset="-120"/>
-              </a:rPr>
-              <a:t>Hoffmann et al. (2022), Training Compute-Optimal LLMs, NeurIPS 35 · Hu et al. (2022), LoRA, ICLR · Dettmers et al. (2023), QLoRA, NeurIPS 36.</a:t>
-            </a:r>
-            <a:endParaRPr lang="en-US" sz="900" dirty="0"/>
-          </a:p>
-        </p:txBody>
-      </p:sp>
-    </p:spTree>
-  </p:cSld>
-  <p:clrMapOvr>
-    <a:masterClrMapping/>
-  </p:clrMapOvr>
-  <p:transition spd="med">
-    <p:fade/>
-  </p:transition>
-</p:sld>
-</file>
-
-<file path=ppt/slides/slide37.xml><?xml version="1.0" encoding="utf-8"?>
+<file path=ppt/slides/slide35.xml><?xml version="1.0" encoding="utf-8"?>
 <p:sld xmlns:a="http://schemas.openxmlformats.org/drawingml/2006/main" xmlns:r="http://schemas.openxmlformats.org/officeDocument/2006/relationships" xmlns:p="http://schemas.openxmlformats.org/presentationml/2006/main">
   <p:cSld name="Slide 37">
     <p:bg>
@@ -41000,7 +39426,7 @@
 </p:sld>
 </file>
 
-<file path=ppt/slides/slide38.xml><?xml version="1.0" encoding="utf-8"?>
+<file path=ppt/slides/slide36.xml><?xml version="1.0" encoding="utf-8"?>
 <p:sld xmlns:a="http://schemas.openxmlformats.org/drawingml/2006/main" xmlns:r="http://schemas.openxmlformats.org/officeDocument/2006/relationships" xmlns:p="http://schemas.openxmlformats.org/presentationml/2006/main">
   <p:cSld name="Slide 38">
     <p:bg>
@@ -41836,7 +40262,7 @@
 </p:sld>
 </file>
 
-<file path=ppt/slides/slide39.xml><?xml version="1.0" encoding="utf-8"?>
+<file path=ppt/slides/slide37.xml><?xml version="1.0" encoding="utf-8"?>
 <p:sld xmlns:a="http://schemas.openxmlformats.org/drawingml/2006/main" xmlns:r="http://schemas.openxmlformats.org/officeDocument/2006/relationships" xmlns:p="http://schemas.openxmlformats.org/presentationml/2006/main">
   <p:cSld name="Slide 39">
     <p:bg>

</xml_diff>